<commit_message>
updated README files and add a blended slides deck
</commit_message>
<xml_diff>
--- a/submission/group-5c-retail-inventory-expiry-management-demo.pptx
+++ b/submission/group-5c-retail-inventory-expiry-management-demo.pptx
@@ -1,23 +1,23 @@
 
 <file path=ppt/presentation.xml><?xml version="1.0" encoding="utf-8"?>
-<ns0:presentation xmlns:ns0="http://schemas.openxmlformats.org/presentationml/2006/main" xmlns:ns1="http://schemas.openxmlformats.org/officeDocument/2006/relationships">
-  <ns0:sldMasterIdLst>
-    <ns0:sldMasterId id="1" ns1:id="rId1"/>
-  </ns0:sldMasterIdLst>
-  <ns0:sldIdLst>
-    <ns0:sldId id="256" ns1:id="rId2"/>
-    <ns0:sldId id="257" ns1:id="rId3"/>
-    <ns0:sldId id="258" ns1:id="rId4"/>
-    <ns0:sldId id="259" ns1:id="rId5"/>
-    <ns0:sldId id="260" ns1:id="rId6"/>
-    <ns0:sldId id="261" ns1:id="rId7"/>
-    <ns0:sldId id="262" ns1:id="rId8"/>
-    <ns0:sldId id="263" ns1:id="rId9"/>
-  </ns0:sldIdLst>
-  <ns0:sldSz cx="12192000" cy="6858000" type="screen16x9"/>
-  <ns0:notesSz cx="6858000" cy="9144000"/>
-  <ns0:defaultTextStyle/>
-</ns0:presentation>
+<p:presentation xmlns:a="http://schemas.openxmlformats.org/drawingml/2006/main" xmlns:r="http://schemas.openxmlformats.org/officeDocument/2006/relationships" xmlns:p="http://schemas.openxmlformats.org/presentationml/2006/main">
+  <p:sldMasterIdLst>
+    <p:sldMasterId id="2147483648" r:id="rId1"/>
+  </p:sldMasterIdLst>
+  <p:sldIdLst>
+    <p:sldId id="256" r:id="rId2"/>
+    <p:sldId id="257" r:id="rId3"/>
+    <p:sldId id="258" r:id="rId4"/>
+    <p:sldId id="259" r:id="rId5"/>
+    <p:sldId id="260" r:id="rId6"/>
+    <p:sldId id="261" r:id="rId7"/>
+    <p:sldId id="262" r:id="rId8"/>
+    <p:sldId id="263" r:id="rId9"/>
+  </p:sldIdLst>
+  <p:sldSz cx="12192000" cy="6858000"/>
+  <p:notesSz cx="6858000" cy="9144000"/>
+  <p:defaultTextStyle/>
+</p:presentation>
 </file>
 
 <file path=ppt/slideLayouts/slideLayout1.xml><?xml version="1.0" encoding="utf-8"?>
@@ -48,6 +48,11 @@
 <file path=ppt/slideMasters/slideMaster1.xml><?xml version="1.0" encoding="utf-8"?>
 <p:sldMaster xmlns:a="http://schemas.openxmlformats.org/drawingml/2006/main" xmlns:r="http://schemas.openxmlformats.org/officeDocument/2006/relationships" xmlns:p="http://schemas.openxmlformats.org/presentationml/2006/main">
   <p:cSld>
+    <p:bg>
+      <p:bgRef idx="1001">
+        <a:schemeClr val="bg1"/>
+      </p:bgRef>
+    </p:bg>
     <p:spTree>
       <p:nvGrpSpPr>
         <p:cNvPr id="1" name=""/>
@@ -66,7 +71,7 @@
   </p:cSld>
   <p:clrMap bg1="lt1" tx1="dk1" bg2="lt2" tx2="dk2" accent1="accent1" accent2="accent2" accent3="accent3" accent4="accent4" accent5="accent5" accent6="accent6" hlink="hlink" folHlink="folHlink"/>
   <p:sldLayoutIdLst>
-    <p:sldLayoutId id="1" r:id="rId1"/>
+    <p:sldLayoutId id="2147483649" r:id="rId1"/>
   </p:sldLayoutIdLst>
   <p:txStyles>
     <p:titleStyle/>
@@ -77,7 +82,7 @@
 </file>
 
 <file path=ppt/slides/slide1.xml><?xml version="1.0" encoding="utf-8"?>
-<p:sld xmlns:a="http://schemas.openxmlformats.org/drawingml/2006/main" xmlns:p="http://schemas.openxmlformats.org/presentationml/2006/main">
+<p:sld xmlns:a="http://schemas.openxmlformats.org/drawingml/2006/main" xmlns:r="http://schemas.openxmlformats.org/officeDocument/2006/relationships" xmlns:p="http://schemas.openxmlformats.org/presentationml/2006/main">
   <p:cSld>
     <p:bg>
       <p:bgPr>
@@ -104,7 +109,7 @@
       <p:sp>
         <p:nvSpPr>
           <p:cNvPr id="2" name="Shape 2"/>
-          <p:cNvSpPr txBox="0"/>
+          <p:cNvSpPr/>
           <p:nvPr/>
         </p:nvSpPr>
         <p:spPr>
@@ -143,10 +148,9 @@
           </a:ln>
         </p:spPr>
         <p:txBody>
-          <a:bodyPr wrap="square" lIns="90000" rIns="90000" tIns="60000" bIns="60000" anchor="ctr"/>
-          <a:lstStyle/>
-          <a:p>
-            <a:pPr/>
+          <a:bodyPr wrap="square" lIns="90000" tIns="60000" rIns="90000" bIns="60000" anchor="ctr"/>
+          <a:lstStyle/>
+          <a:p>
             <a:r>
               <a:rPr lang="en-US" sz="1300" b="1">
                 <a:solidFill>
@@ -180,10 +184,9 @@
           </a:ln>
         </p:spPr>
         <p:txBody>
-          <a:bodyPr wrap="square" lIns="90000" rIns="90000" tIns="60000" bIns="60000" anchor="ctr"/>
-          <a:lstStyle/>
-          <a:p>
-            <a:pPr/>
+          <a:bodyPr wrap="square" lIns="90000" tIns="60000" rIns="90000" bIns="60000" anchor="ctr"/>
+          <a:lstStyle/>
+          <a:p>
             <a:r>
               <a:rPr lang="en-US" sz="3600" b="1">
                 <a:solidFill>
@@ -196,7 +199,6 @@
             <a:endParaRPr lang="en-US" sz="3600"/>
           </a:p>
           <a:p>
-            <a:pPr/>
             <a:r>
               <a:rPr lang="en-US" sz="3600" b="1">
                 <a:solidFill>
@@ -230,10 +232,9 @@
           </a:ln>
         </p:spPr>
         <p:txBody>
-          <a:bodyPr wrap="square" lIns="90000" rIns="90000" tIns="60000" bIns="60000" anchor="ctr"/>
-          <a:lstStyle/>
-          <a:p>
-            <a:pPr/>
+          <a:bodyPr wrap="square" lIns="90000" tIns="60000" rIns="90000" bIns="60000" anchor="ctr"/>
+          <a:lstStyle/>
+          <a:p>
             <a:r>
               <a:rPr lang="en-US" sz="2000" b="0">
                 <a:solidFill>
@@ -250,7 +251,7 @@
       <p:sp>
         <p:nvSpPr>
           <p:cNvPr id="6" name="Shape 6"/>
-          <p:cNvSpPr txBox="0"/>
+          <p:cNvSpPr/>
           <p:nvPr/>
         </p:nvSpPr>
         <p:spPr>
@@ -277,7 +278,7 @@
         </p:nvSpPr>
         <p:spPr>
           <a:xfrm>
-            <a:off x="787400" y="5080000"/>
+            <a:off x="787400" y="5336032"/>
             <a:ext cx="10160000" cy="406400"/>
           </a:xfrm>
           <a:prstGeom prst="rect">
@@ -289,10 +290,9 @@
           </a:ln>
         </p:spPr>
         <p:txBody>
-          <a:bodyPr wrap="square" lIns="90000" rIns="90000" tIns="60000" bIns="60000" anchor="ctr"/>
-          <a:lstStyle/>
-          <a:p>
-            <a:pPr/>
+          <a:bodyPr wrap="square" lIns="90000" tIns="60000" rIns="90000" bIns="60000" anchor="ctr"/>
+          <a:lstStyle/>
+          <a:p>
             <a:r>
               <a:rPr lang="en-US" sz="1600" b="0">
                 <a:solidFill>
@@ -326,10 +326,9 @@
           </a:ln>
         </p:spPr>
         <p:txBody>
-          <a:bodyPr wrap="square" lIns="90000" rIns="90000" tIns="60000" bIns="60000" anchor="ctr"/>
-          <a:lstStyle/>
-          <a:p>
-            <a:pPr/>
+          <a:bodyPr wrap="square" lIns="90000" tIns="60000" rIns="90000" bIns="60000" anchor="ctr"/>
+          <a:lstStyle/>
+          <a:p>
             <a:r>
               <a:rPr lang="en-US" sz="1200" b="0">
                 <a:solidFill>
@@ -363,59 +362,100 @@
           </a:ln>
         </p:spPr>
         <p:txBody>
-          <a:bodyPr wrap="square" lIns="0" rIns="0" tIns="0" bIns="0" anchor="ctr"/>
-          <a:lstStyle/>
-          <a:p>
-            <a:pPr/>
-            <a:r>
-              <a:rPr lang="en-US" sz="1250" b="0">
+          <a:bodyPr wrap="square" lIns="0" tIns="0" rIns="0" bIns="0" anchor="ctr"/>
+          <a:lstStyle/>
+          <a:p>
+            <a:r>
+              <a:rPr lang="en-US" sz="1250" b="0" dirty="0">
                 <a:solidFill>
                   <a:srgbClr val="FFFFFF"/>
                 </a:solidFill>
                 <a:latin typeface="Aptos"/>
               </a:rPr>
-              <a:t>David Oladele</a:t>
-            </a:r>
-            <a:endParaRPr lang="en-US" sz="1250"/>
-          </a:p>
-          <a:p>
-            <a:pPr/>
-            <a:r>
-              <a:rPr lang="en-US" sz="1250" b="0">
+              <a:t>David </a:t>
+            </a:r>
+            <a:r>
+              <a:rPr lang="en-US" sz="1250" b="0" dirty="0" err="1">
                 <a:solidFill>
                   <a:srgbClr val="FFFFFF"/>
                 </a:solidFill>
                 <a:latin typeface="Aptos"/>
               </a:rPr>
-              <a:t>Musibau BOLAJI (Adigson)</a:t>
-            </a:r>
-            <a:endParaRPr lang="en-US" sz="1250"/>
-          </a:p>
-          <a:p>
-            <a:pPr/>
-            <a:r>
-              <a:rPr lang="en-US" sz="1250" b="0">
+              <a:t>Oladele</a:t>
+            </a:r>
+            <a:endParaRPr lang="en-US" sz="1250" dirty="0"/>
+          </a:p>
+          <a:p>
+            <a:r>
+              <a:rPr lang="en-US" sz="1250" b="0" dirty="0" err="1">
                 <a:solidFill>
                   <a:srgbClr val="FFFFFF"/>
                 </a:solidFill>
                 <a:latin typeface="Aptos"/>
               </a:rPr>
-              <a:t>Precious Chisom</a:t>
-            </a:r>
-            <a:endParaRPr lang="en-US" sz="1250"/>
-          </a:p>
-          <a:p>
-            <a:pPr/>
-            <a:r>
-              <a:rPr lang="en-US" sz="1250" b="0">
+              <a:t>Musibau</a:t>
+            </a:r>
+            <a:r>
+              <a:rPr lang="en-US" sz="1250" b="0" dirty="0">
                 <a:solidFill>
                   <a:srgbClr val="FFFFFF"/>
                 </a:solidFill>
                 <a:latin typeface="Aptos"/>
               </a:rPr>
+              <a:t> BOLAJI (</a:t>
+            </a:r>
+            <a:r>
+              <a:rPr lang="en-US" sz="1250" b="0" dirty="0" err="1">
+                <a:solidFill>
+                  <a:srgbClr val="FFFFFF"/>
+                </a:solidFill>
+                <a:latin typeface="Aptos"/>
+              </a:rPr>
+              <a:t>Adigson</a:t>
+            </a:r>
+            <a:r>
+              <a:rPr lang="en-US" sz="1250" b="0" dirty="0">
+                <a:solidFill>
+                  <a:srgbClr val="FFFFFF"/>
+                </a:solidFill>
+                <a:latin typeface="Aptos"/>
+              </a:rPr>
+              <a:t>)</a:t>
+            </a:r>
+            <a:endParaRPr lang="en-US" sz="1250" dirty="0"/>
+          </a:p>
+          <a:p>
+            <a:r>
+              <a:rPr lang="en-US" sz="1250" b="0" dirty="0">
+                <a:solidFill>
+                  <a:srgbClr val="FFFFFF"/>
+                </a:solidFill>
+                <a:latin typeface="Aptos"/>
+              </a:rPr>
+              <a:t>Precious </a:t>
+            </a:r>
+            <a:r>
+              <a:rPr lang="en-US" sz="1250" b="0" dirty="0" err="1">
+                <a:solidFill>
+                  <a:srgbClr val="FFFFFF"/>
+                </a:solidFill>
+                <a:latin typeface="Aptos"/>
+              </a:rPr>
+              <a:t>Chisom</a:t>
+            </a:r>
+            <a:endParaRPr lang="en-US" sz="1250" dirty="0"/>
+          </a:p>
+          <a:p>
+            <a:r>
+              <a:rPr lang="en-US" sz="1250" b="0" dirty="0">
+                <a:solidFill>
+                  <a:srgbClr val="FFFFFF"/>
+                </a:solidFill>
+                <a:latin typeface="Aptos"/>
+              </a:rPr>
               <a:t>Jamila Umar Adam</a:t>
             </a:r>
-            <a:endParaRPr lang="en-US" sz="1250"/>
+            <a:endParaRPr lang="en-US" sz="1250" dirty="0"/>
           </a:p>
         </p:txBody>
       </p:sp>
@@ -439,10 +479,9 @@
           </a:ln>
         </p:spPr>
         <p:txBody>
-          <a:bodyPr wrap="square" lIns="0" rIns="0" tIns="0" bIns="0" anchor="ctr"/>
-          <a:lstStyle/>
-          <a:p>
-            <a:pPr/>
+          <a:bodyPr wrap="square" lIns="0" tIns="0" rIns="0" bIns="0" anchor="ctr"/>
+          <a:lstStyle/>
+          <a:p>
             <a:r>
               <a:rPr lang="en-US" sz="1250" b="0">
                 <a:solidFill>
@@ -455,7 +494,6 @@
             <a:endParaRPr lang="en-US" sz="1250"/>
           </a:p>
           <a:p>
-            <a:pPr/>
             <a:r>
               <a:rPr lang="en-US" sz="1250" b="0">
                 <a:solidFill>
@@ -468,7 +506,6 @@
             <a:endParaRPr lang="en-US" sz="1250"/>
           </a:p>
           <a:p>
-            <a:pPr/>
             <a:r>
               <a:rPr lang="en-US" sz="1250" b="0">
                 <a:solidFill>
@@ -481,7 +518,6 @@
             <a:endParaRPr lang="en-US" sz="1250"/>
           </a:p>
           <a:p>
-            <a:pPr/>
             <a:r>
               <a:rPr lang="en-US" sz="1250" b="0">
                 <a:solidFill>
@@ -504,7 +540,7 @@
 </file>
 
 <file path=ppt/slides/slide2.xml><?xml version="1.0" encoding="utf-8"?>
-<p:sld xmlns:a="http://schemas.openxmlformats.org/drawingml/2006/main" xmlns:p="http://schemas.openxmlformats.org/presentationml/2006/main">
+<p:sld xmlns:a="http://schemas.openxmlformats.org/drawingml/2006/main" xmlns:r="http://schemas.openxmlformats.org/officeDocument/2006/relationships" xmlns:p="http://schemas.openxmlformats.org/presentationml/2006/main">
   <p:cSld>
     <p:bg>
       <p:bgPr>
@@ -548,10 +584,9 @@
           </a:ln>
         </p:spPr>
         <p:txBody>
-          <a:bodyPr wrap="square" lIns="90000" rIns="90000" tIns="60000" bIns="60000" anchor="ctr"/>
-          <a:lstStyle/>
-          <a:p>
-            <a:pPr/>
+          <a:bodyPr wrap="square" lIns="90000" tIns="60000" rIns="90000" bIns="60000" anchor="ctr"/>
+          <a:lstStyle/>
+          <a:p>
             <a:r>
               <a:rPr lang="en-US" sz="1100" b="1">
                 <a:solidFill>
@@ -585,10 +620,9 @@
           </a:ln>
         </p:spPr>
         <p:txBody>
-          <a:bodyPr wrap="square" lIns="90000" rIns="90000" tIns="60000" bIns="60000" anchor="ctr"/>
-          <a:lstStyle/>
-          <a:p>
-            <a:pPr/>
+          <a:bodyPr wrap="square" lIns="90000" tIns="60000" rIns="90000" bIns="60000" anchor="ctr"/>
+          <a:lstStyle/>
+          <a:p>
             <a:r>
               <a:rPr lang="en-US" sz="2700" b="1">
                 <a:solidFill>
@@ -605,7 +639,7 @@
       <p:sp>
         <p:nvSpPr>
           <p:cNvPr id="4" name="Shape 4"/>
-          <p:cNvSpPr txBox="0"/>
+          <p:cNvSpPr/>
           <p:nvPr/>
         </p:nvSpPr>
         <p:spPr>
@@ -627,7 +661,7 @@
       <p:sp>
         <p:nvSpPr>
           <p:cNvPr id="5" name="Shape 5"/>
-          <p:cNvSpPr txBox="0"/>
+          <p:cNvSpPr/>
           <p:nvPr/>
         </p:nvSpPr>
         <p:spPr>
@@ -649,7 +683,7 @@
       <p:sp>
         <p:nvSpPr>
           <p:cNvPr id="6" name="Shape 6"/>
-          <p:cNvSpPr txBox="0"/>
+          <p:cNvSpPr/>
           <p:nvPr/>
         </p:nvSpPr>
         <p:spPr>
@@ -688,10 +722,9 @@
           </a:ln>
         </p:spPr>
         <p:txBody>
-          <a:bodyPr wrap="square" lIns="90000" rIns="90000" tIns="60000" bIns="60000" anchor="ctr"/>
-          <a:lstStyle/>
-          <a:p>
-            <a:pPr/>
+          <a:bodyPr wrap="square" lIns="90000" tIns="60000" rIns="90000" bIns="60000" anchor="ctr"/>
+          <a:lstStyle/>
+          <a:p>
             <a:r>
               <a:rPr lang="en-US" sz="1900" b="1">
                 <a:solidFill>
@@ -725,10 +758,9 @@
           </a:ln>
         </p:spPr>
         <p:txBody>
-          <a:bodyPr wrap="square" lIns="90000" rIns="90000" tIns="60000" bIns="60000" anchor="ctr"/>
-          <a:lstStyle/>
-          <a:p>
-            <a:pPr/>
+          <a:bodyPr wrap="square" lIns="90000" tIns="60000" rIns="90000" bIns="60000" anchor="ctr"/>
+          <a:lstStyle/>
+          <a:p>
             <a:r>
               <a:rPr lang="en-US" sz="1600" b="0">
                 <a:solidFill>
@@ -744,8 +776,8 @@
       </p:sp>
       <p:sp>
         <p:nvSpPr>
-          <p:cNvPr id="8" name="Shape 8"/>
-          <p:cNvSpPr txBox="0"/>
+          <p:cNvPr id="15" name="Shape 8"/>
+          <p:cNvSpPr/>
           <p:nvPr/>
         </p:nvSpPr>
         <p:spPr>
@@ -767,7 +799,7 @@
       <p:sp>
         <p:nvSpPr>
           <p:cNvPr id="9" name="Shape 9"/>
-          <p:cNvSpPr txBox="0"/>
+          <p:cNvSpPr/>
           <p:nvPr/>
         </p:nvSpPr>
         <p:spPr>
@@ -806,10 +838,9 @@
           </a:ln>
         </p:spPr>
         <p:txBody>
-          <a:bodyPr wrap="square" lIns="90000" rIns="90000" tIns="60000" bIns="60000" anchor="ctr"/>
-          <a:lstStyle/>
-          <a:p>
-            <a:pPr/>
+          <a:bodyPr wrap="square" lIns="90000" tIns="60000" rIns="90000" bIns="60000" anchor="ctr"/>
+          <a:lstStyle/>
+          <a:p>
             <a:r>
               <a:rPr lang="en-US" sz="1900" b="1">
                 <a:solidFill>
@@ -843,10 +874,9 @@
           </a:ln>
         </p:spPr>
         <p:txBody>
-          <a:bodyPr wrap="square" lIns="90000" rIns="90000" tIns="60000" bIns="60000" anchor="ctr"/>
-          <a:lstStyle/>
-          <a:p>
-            <a:pPr/>
+          <a:bodyPr wrap="square" lIns="90000" tIns="60000" rIns="90000" bIns="60000" anchor="ctr"/>
+          <a:lstStyle/>
+          <a:p>
             <a:r>
               <a:rPr lang="en-US" sz="1600" b="0">
                 <a:solidFill>
@@ -862,8 +892,8 @@
       </p:sp>
       <p:sp>
         <p:nvSpPr>
-          <p:cNvPr id="11" name="Shape 11"/>
-          <p:cNvSpPr txBox="0"/>
+          <p:cNvPr id="19" name="Shape 11"/>
+          <p:cNvSpPr/>
           <p:nvPr/>
         </p:nvSpPr>
         <p:spPr>
@@ -885,7 +915,7 @@
       <p:sp>
         <p:nvSpPr>
           <p:cNvPr id="12" name="Shape 12"/>
-          <p:cNvSpPr txBox="0"/>
+          <p:cNvSpPr/>
           <p:nvPr/>
         </p:nvSpPr>
         <p:spPr>
@@ -924,10 +954,9 @@
           </a:ln>
         </p:spPr>
         <p:txBody>
-          <a:bodyPr wrap="square" lIns="90000" rIns="90000" tIns="60000" bIns="60000" anchor="ctr"/>
-          <a:lstStyle/>
-          <a:p>
-            <a:pPr/>
+          <a:bodyPr wrap="square" lIns="90000" tIns="60000" rIns="90000" bIns="60000" anchor="ctr"/>
+          <a:lstStyle/>
+          <a:p>
             <a:r>
               <a:rPr lang="en-US" sz="1900" b="1">
                 <a:solidFill>
@@ -961,10 +990,9 @@
           </a:ln>
         </p:spPr>
         <p:txBody>
-          <a:bodyPr wrap="square" lIns="90000" rIns="90000" tIns="60000" bIns="60000" anchor="ctr"/>
-          <a:lstStyle/>
-          <a:p>
-            <a:pPr/>
+          <a:bodyPr wrap="square" lIns="90000" tIns="60000" rIns="90000" bIns="60000" anchor="ctr"/>
+          <a:lstStyle/>
+          <a:p>
             <a:r>
               <a:rPr lang="en-US" sz="1600" b="0">
                 <a:solidFill>
@@ -998,10 +1026,9 @@
           </a:ln>
         </p:spPr>
         <p:txBody>
-          <a:bodyPr wrap="square" lIns="90000" rIns="90000" tIns="60000" bIns="60000" anchor="ctr"/>
-          <a:lstStyle/>
-          <a:p>
-            <a:pPr/>
+          <a:bodyPr wrap="square" lIns="90000" tIns="60000" rIns="90000" bIns="60000" anchor="ctr"/>
+          <a:lstStyle/>
+          <a:p>
             <a:r>
               <a:rPr lang="en-US" sz="1800" b="1">
                 <a:solidFill>
@@ -1035,10 +1062,9 @@
           </a:ln>
         </p:spPr>
         <p:txBody>
-          <a:bodyPr wrap="square" lIns="90000" rIns="90000" tIns="60000" bIns="60000" anchor="ctr"/>
-          <a:lstStyle/>
-          <a:p>
-            <a:pPr/>
+          <a:bodyPr wrap="square" lIns="90000" tIns="60000" rIns="90000" bIns="60000" anchor="ctr"/>
+          <a:lstStyle/>
+          <a:p>
             <a:r>
               <a:rPr lang="en-US" sz="1000" b="0">
                 <a:solidFill>
@@ -1072,10 +1098,9 @@
           </a:ln>
         </p:spPr>
         <p:txBody>
-          <a:bodyPr wrap="square" lIns="90000" rIns="90000" tIns="60000" bIns="60000" anchor="ctr"/>
-          <a:lstStyle/>
-          <a:p>
-            <a:pPr/>
+          <a:bodyPr wrap="square" lIns="90000" tIns="60000" rIns="90000" bIns="60000" anchor="ctr"/>
+          <a:lstStyle/>
+          <a:p>
             <a:r>
               <a:rPr lang="en-US" sz="1000" b="0">
                 <a:solidFill>
@@ -1098,7 +1123,7 @@
 </file>
 
 <file path=ppt/slides/slide3.xml><?xml version="1.0" encoding="utf-8"?>
-<p:sld xmlns:a="http://schemas.openxmlformats.org/drawingml/2006/main" xmlns:p="http://schemas.openxmlformats.org/presentationml/2006/main">
+<p:sld xmlns:a="http://schemas.openxmlformats.org/drawingml/2006/main" xmlns:r="http://schemas.openxmlformats.org/officeDocument/2006/relationships" xmlns:p="http://schemas.openxmlformats.org/presentationml/2006/main">
   <p:cSld>
     <p:bg>
       <p:bgPr>
@@ -1142,10 +1167,9 @@
           </a:ln>
         </p:spPr>
         <p:txBody>
-          <a:bodyPr wrap="square" lIns="90000" rIns="90000" tIns="60000" bIns="60000" anchor="ctr"/>
-          <a:lstStyle/>
-          <a:p>
-            <a:pPr/>
+          <a:bodyPr wrap="square" lIns="90000" tIns="60000" rIns="90000" bIns="60000" anchor="ctr"/>
+          <a:lstStyle/>
+          <a:p>
             <a:r>
               <a:rPr lang="en-US" sz="1100" b="1">
                 <a:solidFill>
@@ -1179,10 +1203,9 @@
           </a:ln>
         </p:spPr>
         <p:txBody>
-          <a:bodyPr wrap="square" lIns="90000" rIns="90000" tIns="60000" bIns="60000" anchor="ctr"/>
-          <a:lstStyle/>
-          <a:p>
-            <a:pPr/>
+          <a:bodyPr wrap="square" lIns="90000" tIns="60000" rIns="90000" bIns="60000" anchor="ctr"/>
+          <a:lstStyle/>
+          <a:p>
             <a:r>
               <a:rPr lang="en-US" sz="2700" b="1">
                 <a:solidFill>
@@ -1199,7 +1222,7 @@
       <p:sp>
         <p:nvSpPr>
           <p:cNvPr id="4" name="Shape 4"/>
-          <p:cNvSpPr txBox="0"/>
+          <p:cNvSpPr/>
           <p:nvPr/>
         </p:nvSpPr>
         <p:spPr>
@@ -1221,7 +1244,7 @@
       <p:sp>
         <p:nvSpPr>
           <p:cNvPr id="5" name="Shape 5"/>
-          <p:cNvSpPr txBox="0"/>
+          <p:cNvSpPr/>
           <p:nvPr/>
         </p:nvSpPr>
         <p:spPr>
@@ -1240,10 +1263,9 @@
           </a:ln>
         </p:spPr>
         <p:txBody>
-          <a:bodyPr wrap="square" lIns="90000" rIns="90000" tIns="60000" bIns="60000" anchor="ctr"/>
-          <a:lstStyle/>
-          <a:p>
-            <a:pPr/>
+          <a:bodyPr wrap="square" lIns="90000" tIns="60000" rIns="90000" bIns="60000" anchor="ctr"/>
+          <a:lstStyle/>
+          <a:p>
             <a:r>
               <a:rPr lang="en-US" sz="1500" b="1">
                 <a:solidFill>
@@ -1256,7 +1278,6 @@
             <a:endParaRPr lang="en-US" sz="1500"/>
           </a:p>
           <a:p>
-            <a:pPr/>
             <a:r>
               <a:rPr lang="en-US" sz="1500" b="1">
                 <a:solidFill>
@@ -1273,7 +1294,7 @@
       <p:sp>
         <p:nvSpPr>
           <p:cNvPr id="7" name="Shape 7"/>
-          <p:cNvSpPr txBox="0"/>
+          <p:cNvSpPr/>
           <p:nvPr/>
         </p:nvSpPr>
         <p:spPr>
@@ -1292,10 +1313,9 @@
           </a:ln>
         </p:spPr>
         <p:txBody>
-          <a:bodyPr wrap="square" lIns="90000" rIns="90000" tIns="60000" bIns="60000" anchor="ctr"/>
-          <a:lstStyle/>
-          <a:p>
-            <a:pPr/>
+          <a:bodyPr wrap="square" lIns="90000" tIns="60000" rIns="90000" bIns="60000" anchor="ctr"/>
+          <a:lstStyle/>
+          <a:p>
             <a:r>
               <a:rPr lang="en-US" sz="1500" b="1">
                 <a:solidFill>
@@ -1308,7 +1328,6 @@
             <a:endParaRPr lang="en-US" sz="1500"/>
           </a:p>
           <a:p>
-            <a:pPr/>
             <a:r>
               <a:rPr lang="en-US" sz="1500" b="1">
                 <a:solidFill>
@@ -1325,7 +1344,7 @@
       <p:sp>
         <p:nvSpPr>
           <p:cNvPr id="9" name="Shape 9"/>
-          <p:cNvSpPr txBox="0"/>
+          <p:cNvSpPr/>
           <p:nvPr/>
         </p:nvSpPr>
         <p:spPr>
@@ -1344,10 +1363,9 @@
           </a:ln>
         </p:spPr>
         <p:txBody>
-          <a:bodyPr wrap="square" lIns="90000" rIns="90000" tIns="60000" bIns="60000" anchor="ctr"/>
-          <a:lstStyle/>
-          <a:p>
-            <a:pPr/>
+          <a:bodyPr wrap="square" lIns="90000" tIns="60000" rIns="90000" bIns="60000" anchor="ctr"/>
+          <a:lstStyle/>
+          <a:p>
             <a:r>
               <a:rPr lang="en-US" sz="1500" b="1">
                 <a:solidFill>
@@ -1360,7 +1378,6 @@
             <a:endParaRPr lang="en-US" sz="1500"/>
           </a:p>
           <a:p>
-            <a:pPr/>
             <a:r>
               <a:rPr lang="en-US" sz="1500" b="1">
                 <a:solidFill>
@@ -1377,7 +1394,7 @@
       <p:sp>
         <p:nvSpPr>
           <p:cNvPr id="11" name="Shape 11"/>
-          <p:cNvSpPr txBox="0"/>
+          <p:cNvSpPr/>
           <p:nvPr/>
         </p:nvSpPr>
         <p:spPr>
@@ -1396,10 +1413,9 @@
           </a:ln>
         </p:spPr>
         <p:txBody>
-          <a:bodyPr wrap="square" lIns="90000" rIns="90000" tIns="60000" bIns="60000" anchor="ctr"/>
-          <a:lstStyle/>
-          <a:p>
-            <a:pPr/>
+          <a:bodyPr wrap="square" lIns="90000" tIns="60000" rIns="90000" bIns="60000" anchor="ctr"/>
+          <a:lstStyle/>
+          <a:p>
             <a:r>
               <a:rPr lang="en-US" sz="1500" b="1">
                 <a:solidFill>
@@ -1412,7 +1428,6 @@
             <a:endParaRPr lang="en-US" sz="1500"/>
           </a:p>
           <a:p>
-            <a:pPr/>
             <a:r>
               <a:rPr lang="en-US" sz="1500" b="1">
                 <a:solidFill>
@@ -1446,10 +1461,9 @@
           </a:ln>
         </p:spPr>
         <p:txBody>
-          <a:bodyPr wrap="square" lIns="90000" rIns="90000" tIns="60000" bIns="60000" anchor="ctr"/>
-          <a:lstStyle/>
-          <a:p>
-            <a:pPr/>
+          <a:bodyPr wrap="square" lIns="90000" tIns="60000" rIns="90000" bIns="60000" anchor="ctr"/>
+          <a:lstStyle/>
+          <a:p>
             <a:r>
               <a:rPr lang="en-US" sz="2200" b="1">
                 <a:solidFill>
@@ -1483,10 +1497,9 @@
           </a:ln>
         </p:spPr>
         <p:txBody>
-          <a:bodyPr wrap="square" lIns="90000" rIns="90000" tIns="60000" bIns="60000" anchor="ctr"/>
-          <a:lstStyle/>
-          <a:p>
-            <a:pPr/>
+          <a:bodyPr wrap="square" lIns="90000" tIns="60000" rIns="90000" bIns="60000" anchor="ctr"/>
+          <a:lstStyle/>
+          <a:p>
             <a:r>
               <a:rPr lang="en-US" sz="2200" b="1">
                 <a:solidFill>
@@ -1520,10 +1533,9 @@
           </a:ln>
         </p:spPr>
         <p:txBody>
-          <a:bodyPr wrap="square" lIns="90000" rIns="90000" tIns="60000" bIns="60000" anchor="ctr"/>
-          <a:lstStyle/>
-          <a:p>
-            <a:pPr/>
+          <a:bodyPr wrap="square" lIns="90000" tIns="60000" rIns="90000" bIns="60000" anchor="ctr"/>
+          <a:lstStyle/>
+          <a:p>
             <a:r>
               <a:rPr lang="en-US" sz="2200" b="1">
                 <a:solidFill>
@@ -1557,10 +1569,9 @@
           </a:ln>
         </p:spPr>
         <p:txBody>
-          <a:bodyPr wrap="square" lIns="90000" rIns="90000" tIns="60000" bIns="60000" anchor="ctr"/>
-          <a:lstStyle/>
-          <a:p>
-            <a:pPr/>
+          <a:bodyPr wrap="square" lIns="90000" tIns="60000" rIns="90000" bIns="60000" anchor="ctr"/>
+          <a:lstStyle/>
+          <a:p>
             <a:r>
               <a:rPr lang="en-US" sz="1600" b="0">
                 <a:solidFill>
@@ -1594,10 +1605,9 @@
           </a:ln>
         </p:spPr>
         <p:txBody>
-          <a:bodyPr wrap="square" lIns="90000" rIns="90000" tIns="60000" bIns="60000" anchor="ctr"/>
-          <a:lstStyle/>
-          <a:p>
-            <a:pPr/>
+          <a:bodyPr wrap="square" lIns="90000" tIns="60000" rIns="90000" bIns="60000" anchor="ctr"/>
+          <a:lstStyle/>
+          <a:p>
             <a:r>
               <a:rPr lang="en-US" sz="1600" b="1">
                 <a:solidFill>
@@ -1631,10 +1641,9 @@
           </a:ln>
         </p:spPr>
         <p:txBody>
-          <a:bodyPr wrap="square" lIns="90000" rIns="90000" tIns="60000" bIns="60000" anchor="ctr"/>
-          <a:lstStyle/>
-          <a:p>
-            <a:pPr/>
+          <a:bodyPr wrap="square" lIns="90000" tIns="60000" rIns="90000" bIns="60000" anchor="ctr"/>
+          <a:lstStyle/>
+          <a:p>
             <a:r>
               <a:rPr lang="en-US" sz="1000" b="0">
                 <a:solidFill>
@@ -1668,10 +1677,9 @@
           </a:ln>
         </p:spPr>
         <p:txBody>
-          <a:bodyPr wrap="square" lIns="90000" rIns="90000" tIns="60000" bIns="60000" anchor="ctr"/>
-          <a:lstStyle/>
-          <a:p>
-            <a:pPr/>
+          <a:bodyPr wrap="square" lIns="90000" tIns="60000" rIns="90000" bIns="60000" anchor="ctr"/>
+          <a:lstStyle/>
+          <a:p>
             <a:r>
               <a:rPr lang="en-US" sz="1000" b="0">
                 <a:solidFill>
@@ -1694,7 +1702,7 @@
 </file>
 
 <file path=ppt/slides/slide4.xml><?xml version="1.0" encoding="utf-8"?>
-<p:sld xmlns:a="http://schemas.openxmlformats.org/drawingml/2006/main" xmlns:p="http://schemas.openxmlformats.org/presentationml/2006/main">
+<p:sld xmlns:a="http://schemas.openxmlformats.org/drawingml/2006/main" xmlns:r="http://schemas.openxmlformats.org/officeDocument/2006/relationships" xmlns:p="http://schemas.openxmlformats.org/presentationml/2006/main">
   <p:cSld>
     <p:bg>
       <p:bgPr>
@@ -1738,10 +1746,9 @@
           </a:ln>
         </p:spPr>
         <p:txBody>
-          <a:bodyPr wrap="square" lIns="90000" rIns="90000" tIns="60000" bIns="60000" anchor="ctr"/>
-          <a:lstStyle/>
-          <a:p>
-            <a:pPr/>
+          <a:bodyPr wrap="square" lIns="90000" tIns="60000" rIns="90000" bIns="60000" anchor="ctr"/>
+          <a:lstStyle/>
+          <a:p>
             <a:r>
               <a:rPr lang="en-US" sz="1100" b="1">
                 <a:solidFill>
@@ -1775,10 +1782,9 @@
           </a:ln>
         </p:spPr>
         <p:txBody>
-          <a:bodyPr wrap="square" lIns="90000" rIns="90000" tIns="60000" bIns="60000" anchor="ctr"/>
-          <a:lstStyle/>
-          <a:p>
-            <a:pPr/>
+          <a:bodyPr wrap="square" lIns="90000" tIns="60000" rIns="90000" bIns="60000" anchor="ctr"/>
+          <a:lstStyle/>
+          <a:p>
             <a:r>
               <a:rPr lang="en-US" sz="2700" b="1">
                 <a:solidFill>
@@ -1795,7 +1801,7 @@
       <p:sp>
         <p:nvSpPr>
           <p:cNvPr id="4" name="Shape 4"/>
-          <p:cNvSpPr txBox="0"/>
+          <p:cNvSpPr/>
           <p:nvPr/>
         </p:nvSpPr>
         <p:spPr>
@@ -1817,7 +1823,7 @@
       <p:sp>
         <p:nvSpPr>
           <p:cNvPr id="5" name="Shape 5"/>
-          <p:cNvSpPr txBox="0"/>
+          <p:cNvSpPr/>
           <p:nvPr/>
         </p:nvSpPr>
         <p:spPr>
@@ -1856,10 +1862,9 @@
           </a:ln>
         </p:spPr>
         <p:txBody>
-          <a:bodyPr wrap="square" lIns="90000" rIns="90000" tIns="60000" bIns="60000" anchor="ctr"/>
-          <a:lstStyle/>
-          <a:p>
-            <a:pPr/>
+          <a:bodyPr wrap="square" lIns="90000" tIns="60000" rIns="90000" bIns="60000" anchor="ctr"/>
+          <a:lstStyle/>
+          <a:p>
             <a:r>
               <a:rPr lang="en-US" sz="1700" b="0">
                 <a:solidFill>
@@ -1876,7 +1881,7 @@
       <p:sp>
         <p:nvSpPr>
           <p:cNvPr id="7" name="Shape 7"/>
-          <p:cNvSpPr txBox="0"/>
+          <p:cNvSpPr/>
           <p:nvPr/>
         </p:nvSpPr>
         <p:spPr>
@@ -1915,10 +1920,9 @@
           </a:ln>
         </p:spPr>
         <p:txBody>
-          <a:bodyPr wrap="square" lIns="90000" rIns="90000" tIns="60000" bIns="60000" anchor="ctr"/>
-          <a:lstStyle/>
-          <a:p>
-            <a:pPr/>
+          <a:bodyPr wrap="square" lIns="90000" tIns="60000" rIns="90000" bIns="60000" anchor="ctr"/>
+          <a:lstStyle/>
+          <a:p>
             <a:r>
               <a:rPr lang="en-US" sz="1700" b="0">
                 <a:solidFill>
@@ -1935,7 +1939,7 @@
       <p:sp>
         <p:nvSpPr>
           <p:cNvPr id="9" name="Shape 9"/>
-          <p:cNvSpPr txBox="0"/>
+          <p:cNvSpPr/>
           <p:nvPr/>
         </p:nvSpPr>
         <p:spPr>
@@ -1974,10 +1978,9 @@
           </a:ln>
         </p:spPr>
         <p:txBody>
-          <a:bodyPr wrap="square" lIns="90000" rIns="90000" tIns="60000" bIns="60000" anchor="ctr"/>
-          <a:lstStyle/>
-          <a:p>
-            <a:pPr/>
+          <a:bodyPr wrap="square" lIns="90000" tIns="60000" rIns="90000" bIns="60000" anchor="ctr"/>
+          <a:lstStyle/>
+          <a:p>
             <a:r>
               <a:rPr lang="en-US" sz="1700" b="0">
                 <a:solidFill>
@@ -1994,7 +1997,7 @@
       <p:sp>
         <p:nvSpPr>
           <p:cNvPr id="11" name="Shape 11"/>
-          <p:cNvSpPr txBox="0"/>
+          <p:cNvSpPr/>
           <p:nvPr/>
         </p:nvSpPr>
         <p:spPr>
@@ -2033,10 +2036,9 @@
           </a:ln>
         </p:spPr>
         <p:txBody>
-          <a:bodyPr wrap="square" lIns="90000" rIns="90000" tIns="60000" bIns="60000" anchor="ctr"/>
-          <a:lstStyle/>
-          <a:p>
-            <a:pPr/>
+          <a:bodyPr wrap="square" lIns="90000" tIns="60000" rIns="90000" bIns="60000" anchor="ctr"/>
+          <a:lstStyle/>
+          <a:p>
             <a:r>
               <a:rPr lang="en-US" sz="1700" b="0">
                 <a:solidFill>
@@ -2053,7 +2055,7 @@
       <p:sp>
         <p:nvSpPr>
           <p:cNvPr id="13" name="Shape 13"/>
-          <p:cNvSpPr txBox="0"/>
+          <p:cNvSpPr/>
           <p:nvPr/>
         </p:nvSpPr>
         <p:spPr>
@@ -2092,10 +2094,9 @@
           </a:ln>
         </p:spPr>
         <p:txBody>
-          <a:bodyPr wrap="square" lIns="90000" rIns="90000" tIns="60000" bIns="60000" anchor="ctr"/>
-          <a:lstStyle/>
-          <a:p>
-            <a:pPr/>
+          <a:bodyPr wrap="square" lIns="90000" tIns="60000" rIns="90000" bIns="60000" anchor="ctr"/>
+          <a:lstStyle/>
+          <a:p>
             <a:r>
               <a:rPr lang="en-US" sz="1700" b="0">
                 <a:solidFill>
@@ -2129,10 +2130,9 @@
           </a:ln>
         </p:spPr>
         <p:txBody>
-          <a:bodyPr wrap="square" lIns="90000" rIns="90000" tIns="60000" bIns="60000" anchor="ctr"/>
-          <a:lstStyle/>
-          <a:p>
-            <a:pPr/>
+          <a:bodyPr wrap="square" lIns="90000" tIns="60000" rIns="90000" bIns="60000" anchor="ctr"/>
+          <a:lstStyle/>
+          <a:p>
             <a:r>
               <a:rPr lang="en-US" sz="1300" b="0">
                 <a:solidFill>
@@ -2166,10 +2166,9 @@
           </a:ln>
         </p:spPr>
         <p:txBody>
-          <a:bodyPr wrap="square" lIns="90000" rIns="90000" tIns="60000" bIns="60000" anchor="ctr"/>
-          <a:lstStyle/>
-          <a:p>
-            <a:pPr/>
+          <a:bodyPr wrap="square" lIns="90000" tIns="60000" rIns="90000" bIns="60000" anchor="ctr"/>
+          <a:lstStyle/>
+          <a:p>
             <a:r>
               <a:rPr lang="en-US" sz="1000" b="0">
                 <a:solidFill>
@@ -2203,10 +2202,9 @@
           </a:ln>
         </p:spPr>
         <p:txBody>
-          <a:bodyPr wrap="square" lIns="90000" rIns="90000" tIns="60000" bIns="60000" anchor="ctr"/>
-          <a:lstStyle/>
-          <a:p>
-            <a:pPr/>
+          <a:bodyPr wrap="square" lIns="90000" tIns="60000" rIns="90000" bIns="60000" anchor="ctr"/>
+          <a:lstStyle/>
+          <a:p>
             <a:r>
               <a:rPr lang="en-US" sz="1000" b="0">
                 <a:solidFill>
@@ -2229,7 +2227,7 @@
 </file>
 
 <file path=ppt/slides/slide5.xml><?xml version="1.0" encoding="utf-8"?>
-<p:sld xmlns:a="http://schemas.openxmlformats.org/drawingml/2006/main" xmlns:p="http://schemas.openxmlformats.org/presentationml/2006/main">
+<p:sld xmlns:a="http://schemas.openxmlformats.org/drawingml/2006/main" xmlns:r="http://schemas.openxmlformats.org/officeDocument/2006/relationships" xmlns:p="http://schemas.openxmlformats.org/presentationml/2006/main">
   <p:cSld>
     <p:bg>
       <p:bgPr>
@@ -2273,10 +2271,9 @@
           </a:ln>
         </p:spPr>
         <p:txBody>
-          <a:bodyPr wrap="square" lIns="90000" rIns="90000" tIns="60000" bIns="60000" anchor="ctr"/>
-          <a:lstStyle/>
-          <a:p>
-            <a:pPr/>
+          <a:bodyPr wrap="square" lIns="90000" tIns="60000" rIns="90000" bIns="60000" anchor="ctr"/>
+          <a:lstStyle/>
+          <a:p>
             <a:r>
               <a:rPr lang="en-US" sz="1100" b="1">
                 <a:solidFill>
@@ -2310,10 +2307,9 @@
           </a:ln>
         </p:spPr>
         <p:txBody>
-          <a:bodyPr wrap="square" lIns="90000" rIns="90000" tIns="60000" bIns="60000" anchor="ctr"/>
-          <a:lstStyle/>
-          <a:p>
-            <a:pPr/>
+          <a:bodyPr wrap="square" lIns="90000" tIns="60000" rIns="90000" bIns="60000" anchor="ctr"/>
+          <a:lstStyle/>
+          <a:p>
             <a:r>
               <a:rPr lang="en-US" sz="2700" b="1">
                 <a:solidFill>
@@ -2330,7 +2326,7 @@
       <p:sp>
         <p:nvSpPr>
           <p:cNvPr id="4" name="Shape 4"/>
-          <p:cNvSpPr txBox="0"/>
+          <p:cNvSpPr/>
           <p:nvPr/>
         </p:nvSpPr>
         <p:spPr>
@@ -2352,7 +2348,7 @@
       <p:sp>
         <p:nvSpPr>
           <p:cNvPr id="5" name="Shape 5"/>
-          <p:cNvSpPr txBox="0"/>
+          <p:cNvSpPr/>
           <p:nvPr/>
         </p:nvSpPr>
         <p:spPr>
@@ -2391,10 +2387,9 @@
           </a:ln>
         </p:spPr>
         <p:txBody>
-          <a:bodyPr wrap="square" lIns="90000" rIns="90000" tIns="60000" bIns="60000" anchor="ctr"/>
-          <a:lstStyle/>
-          <a:p>
-            <a:pPr/>
+          <a:bodyPr wrap="square" lIns="90000" tIns="60000" rIns="90000" bIns="60000" anchor="ctr"/>
+          <a:lstStyle/>
+          <a:p>
             <a:r>
               <a:rPr lang="en-US" sz="1200" b="1">
                 <a:solidFill>
@@ -2428,10 +2423,9 @@
           </a:ln>
         </p:spPr>
         <p:txBody>
-          <a:bodyPr wrap="square" lIns="90000" rIns="90000" tIns="60000" bIns="60000" anchor="ctr"/>
-          <a:lstStyle/>
-          <a:p>
-            <a:pPr/>
+          <a:bodyPr wrap="square" lIns="90000" tIns="60000" rIns="90000" bIns="60000" anchor="ctr"/>
+          <a:lstStyle/>
+          <a:p>
             <a:r>
               <a:rPr lang="en-US" sz="1700" b="0">
                 <a:solidFill>
@@ -2448,7 +2442,7 @@
       <p:sp>
         <p:nvSpPr>
           <p:cNvPr id="8" name="Shape 8"/>
-          <p:cNvSpPr txBox="0"/>
+          <p:cNvSpPr/>
           <p:nvPr/>
         </p:nvSpPr>
         <p:spPr>
@@ -2487,10 +2481,9 @@
           </a:ln>
         </p:spPr>
         <p:txBody>
-          <a:bodyPr wrap="square" lIns="90000" rIns="90000" tIns="60000" bIns="60000" anchor="ctr"/>
-          <a:lstStyle/>
-          <a:p>
-            <a:pPr/>
+          <a:bodyPr wrap="square" lIns="90000" tIns="60000" rIns="90000" bIns="60000" anchor="ctr"/>
+          <a:lstStyle/>
+          <a:p>
             <a:r>
               <a:rPr lang="en-US" sz="1200" b="1">
                 <a:solidFill>
@@ -2524,10 +2517,9 @@
           </a:ln>
         </p:spPr>
         <p:txBody>
-          <a:bodyPr wrap="square" lIns="90000" rIns="90000" tIns="60000" bIns="60000" anchor="ctr"/>
-          <a:lstStyle/>
-          <a:p>
-            <a:pPr/>
+          <a:bodyPr wrap="square" lIns="90000" tIns="60000" rIns="90000" bIns="60000" anchor="ctr"/>
+          <a:lstStyle/>
+          <a:p>
             <a:r>
               <a:rPr lang="en-US" sz="1700" b="0">
                 <a:solidFill>
@@ -2540,7 +2532,6 @@
             <a:endParaRPr lang="en-US" sz="1700"/>
           </a:p>
           <a:p>
-            <a:pPr/>
             <a:r>
               <a:rPr lang="en-US" sz="1700" b="0">
                 <a:solidFill>
@@ -2553,7 +2544,6 @@
             <a:endParaRPr lang="en-US" sz="1700"/>
           </a:p>
           <a:p>
-            <a:pPr/>
             <a:r>
               <a:rPr lang="en-US" sz="1700" b="0">
                 <a:solidFill>
@@ -2566,20 +2556,9 @@
             <a:endParaRPr lang="en-US" sz="1700"/>
           </a:p>
           <a:p>
-            <a:pPr/>
-            <a:r>
-              <a:rPr lang="en-US" sz="1700" b="0">
-                <a:solidFill>
-                  <a:srgbClr val="243746"/>
-                </a:solidFill>
-                <a:latin typeface="Aptos"/>
-              </a:rPr>
-              <a:t/>
-            </a:r>
             <a:endParaRPr lang="en-US" sz="1700"/>
           </a:p>
           <a:p>
-            <a:pPr/>
             <a:r>
               <a:rPr lang="en-US" sz="1700" b="0">
                 <a:solidFill>
@@ -2613,10 +2592,9 @@
           </a:ln>
         </p:spPr>
         <p:txBody>
-          <a:bodyPr wrap="square" lIns="90000" rIns="90000" tIns="60000" bIns="60000" anchor="ctr"/>
-          <a:lstStyle/>
-          <a:p>
-            <a:pPr/>
+          <a:bodyPr wrap="square" lIns="90000" tIns="60000" rIns="90000" bIns="60000" anchor="ctr"/>
+          <a:lstStyle/>
+          <a:p>
             <a:r>
               <a:rPr lang="en-US" sz="1500" b="1">
                 <a:solidFill>
@@ -2650,10 +2628,9 @@
           </a:ln>
         </p:spPr>
         <p:txBody>
-          <a:bodyPr wrap="square" lIns="90000" rIns="90000" tIns="60000" bIns="60000" anchor="ctr"/>
-          <a:lstStyle/>
-          <a:p>
-            <a:pPr/>
+          <a:bodyPr wrap="square" lIns="90000" tIns="60000" rIns="90000" bIns="60000" anchor="ctr"/>
+          <a:lstStyle/>
+          <a:p>
             <a:r>
               <a:rPr lang="en-US" sz="1000" b="0">
                 <a:solidFill>
@@ -2687,10 +2664,9 @@
           </a:ln>
         </p:spPr>
         <p:txBody>
-          <a:bodyPr wrap="square" lIns="90000" rIns="90000" tIns="60000" bIns="60000" anchor="ctr"/>
-          <a:lstStyle/>
-          <a:p>
-            <a:pPr/>
+          <a:bodyPr wrap="square" lIns="90000" tIns="60000" rIns="90000" bIns="60000" anchor="ctr"/>
+          <a:lstStyle/>
+          <a:p>
             <a:r>
               <a:rPr lang="en-US" sz="1000" b="0">
                 <a:solidFill>
@@ -2713,7 +2689,7 @@
 </file>
 
 <file path=ppt/slides/slide6.xml><?xml version="1.0" encoding="utf-8"?>
-<p:sld xmlns:a="http://schemas.openxmlformats.org/drawingml/2006/main" xmlns:p="http://schemas.openxmlformats.org/presentationml/2006/main" xmlns:r="http://schemas.openxmlformats.org/officeDocument/2006/relationships">
+<p:sld xmlns:a="http://schemas.openxmlformats.org/drawingml/2006/main" xmlns:r="http://schemas.openxmlformats.org/officeDocument/2006/relationships" xmlns:p="http://schemas.openxmlformats.org/presentationml/2006/main">
   <p:cSld>
     <p:spTree>
       <p:nvGrpSpPr>
@@ -2749,10 +2725,9 @@
           </a:ln>
         </p:spPr>
         <p:txBody>
-          <a:bodyPr wrap="square" lIns="0" rIns="0" tIns="0" bIns="0" anchor="ctr"/>
-          <a:lstStyle/>
-          <a:p>
-            <a:pPr/>
+          <a:bodyPr wrap="square" lIns="0" tIns="0" rIns="0" bIns="0" anchor="ctr"/>
+          <a:lstStyle/>
+          <a:p>
             <a:r>
               <a:rPr lang="en-US" sz="1100" b="1">
                 <a:solidFill>
@@ -2786,10 +2761,9 @@
           </a:ln>
         </p:spPr>
         <p:txBody>
-          <a:bodyPr wrap="square" lIns="0" rIns="0" tIns="0" bIns="0" anchor="ctr"/>
-          <a:lstStyle/>
-          <a:p>
-            <a:pPr/>
+          <a:bodyPr wrap="square" lIns="0" tIns="0" rIns="0" bIns="0" anchor="ctr"/>
+          <a:lstStyle/>
+          <a:p>
             <a:r>
               <a:rPr lang="en-US" sz="2700" b="1">
                 <a:solidFill>
@@ -2845,10 +2819,9 @@
           </a:ln>
         </p:spPr>
         <p:txBody>
-          <a:bodyPr wrap="square" lIns="0" rIns="0" tIns="0" bIns="0" anchor="ctr"/>
-          <a:lstStyle/>
-          <a:p>
-            <a:pPr/>
+          <a:bodyPr wrap="square" lIns="0" tIns="0" rIns="0" bIns="0" anchor="ctr"/>
+          <a:lstStyle/>
+          <a:p>
             <a:r>
               <a:rPr lang="en-US" sz="900" b="0">
                 <a:solidFill>
@@ -2882,10 +2855,9 @@
           </a:ln>
         </p:spPr>
         <p:txBody>
-          <a:bodyPr wrap="square" lIns="0" rIns="0" tIns="0" bIns="0" anchor="ctr"/>
-          <a:lstStyle/>
-          <a:p>
-            <a:pPr/>
+          <a:bodyPr wrap="square" lIns="0" tIns="0" rIns="0" bIns="0" anchor="ctr"/>
+          <a:lstStyle/>
+          <a:p>
             <a:r>
               <a:rPr lang="en-US" sz="900" b="0">
                 <a:solidFill>
@@ -2941,10 +2913,9 @@
           </a:ln>
         </p:spPr>
         <p:txBody>
-          <a:bodyPr wrap="square" lIns="0" rIns="0" tIns="0" bIns="0" anchor="ctr"/>
-          <a:lstStyle/>
-          <a:p>
-            <a:pPr/>
+          <a:bodyPr wrap="square" lIns="0" tIns="0" rIns="0" bIns="0" anchor="ctr"/>
+          <a:lstStyle/>
+          <a:p>
             <a:r>
               <a:rPr lang="en-US" sz="1350" b="1">
                 <a:solidFill>
@@ -3000,10 +2971,9 @@
           </a:ln>
         </p:spPr>
         <p:txBody>
-          <a:bodyPr wrap="square" lIns="0" rIns="0" tIns="0" bIns="0" anchor="ctr"/>
-          <a:lstStyle/>
-          <a:p>
-            <a:pPr/>
+          <a:bodyPr wrap="square" lIns="0" tIns="0" rIns="0" bIns="0" anchor="ctr"/>
+          <a:lstStyle/>
+          <a:p>
             <a:r>
               <a:rPr lang="en-US" sz="1350" b="1">
                 <a:solidFill>
@@ -3026,7 +2996,7 @@
 </file>
 
 <file path=ppt/slides/slide7.xml><?xml version="1.0" encoding="utf-8"?>
-<p:sld xmlns:a="http://schemas.openxmlformats.org/drawingml/2006/main" xmlns:p="http://schemas.openxmlformats.org/presentationml/2006/main" xmlns:r="http://schemas.openxmlformats.org/officeDocument/2006/relationships">
+<p:sld xmlns:a="http://schemas.openxmlformats.org/drawingml/2006/main" xmlns:r="http://schemas.openxmlformats.org/officeDocument/2006/relationships" xmlns:p="http://schemas.openxmlformats.org/presentationml/2006/main">
   <p:cSld>
     <p:spTree>
       <p:nvGrpSpPr>
@@ -3062,10 +3032,9 @@
           </a:ln>
         </p:spPr>
         <p:txBody>
-          <a:bodyPr wrap="square" lIns="0" rIns="0" tIns="0" bIns="0" anchor="ctr"/>
-          <a:lstStyle/>
-          <a:p>
-            <a:pPr/>
+          <a:bodyPr wrap="square" lIns="0" tIns="0" rIns="0" bIns="0" anchor="ctr"/>
+          <a:lstStyle/>
+          <a:p>
             <a:r>
               <a:rPr lang="en-US" sz="1100" b="1">
                 <a:solidFill>
@@ -3099,10 +3068,9 @@
           </a:ln>
         </p:spPr>
         <p:txBody>
-          <a:bodyPr wrap="square" lIns="0" rIns="0" tIns="0" bIns="0" anchor="ctr"/>
-          <a:lstStyle/>
-          <a:p>
-            <a:pPr/>
+          <a:bodyPr wrap="square" lIns="0" tIns="0" rIns="0" bIns="0" anchor="ctr"/>
+          <a:lstStyle/>
+          <a:p>
             <a:r>
               <a:rPr lang="en-US" sz="2700" b="1">
                 <a:solidFill>
@@ -3158,10 +3126,9 @@
           </a:ln>
         </p:spPr>
         <p:txBody>
-          <a:bodyPr wrap="square" lIns="0" rIns="0" tIns="0" bIns="0" anchor="ctr"/>
-          <a:lstStyle/>
-          <a:p>
-            <a:pPr/>
+          <a:bodyPr wrap="square" lIns="0" tIns="0" rIns="0" bIns="0" anchor="ctr"/>
+          <a:lstStyle/>
+          <a:p>
             <a:r>
               <a:rPr lang="en-US" sz="900" b="0">
                 <a:solidFill>
@@ -3195,10 +3162,9 @@
           </a:ln>
         </p:spPr>
         <p:txBody>
-          <a:bodyPr wrap="square" lIns="0" rIns="0" tIns="0" bIns="0" anchor="ctr"/>
-          <a:lstStyle/>
-          <a:p>
-            <a:pPr/>
+          <a:bodyPr wrap="square" lIns="0" tIns="0" rIns="0" bIns="0" anchor="ctr"/>
+          <a:lstStyle/>
+          <a:p>
             <a:r>
               <a:rPr lang="en-US" sz="900" b="0">
                 <a:solidFill>
@@ -3254,10 +3220,9 @@
           </a:ln>
         </p:spPr>
         <p:txBody>
-          <a:bodyPr wrap="square" lIns="0" rIns="0" tIns="0" bIns="0" anchor="ctr"/>
-          <a:lstStyle/>
-          <a:p>
-            <a:pPr/>
+          <a:bodyPr wrap="square" lIns="0" tIns="0" rIns="0" bIns="0" anchor="ctr"/>
+          <a:lstStyle/>
+          <a:p>
             <a:r>
               <a:rPr lang="en-US" sz="1350" b="1">
                 <a:solidFill>
@@ -3313,10 +3278,9 @@
           </a:ln>
         </p:spPr>
         <p:txBody>
-          <a:bodyPr wrap="square" lIns="0" rIns="0" tIns="0" bIns="0" anchor="ctr"/>
-          <a:lstStyle/>
-          <a:p>
-            <a:pPr/>
+          <a:bodyPr wrap="square" lIns="0" tIns="0" rIns="0" bIns="0" anchor="ctr"/>
+          <a:lstStyle/>
+          <a:p>
             <a:r>
               <a:rPr lang="en-US" sz="1350" b="1">
                 <a:solidFill>
@@ -3339,7 +3303,7 @@
 </file>
 
 <file path=ppt/slides/slide8.xml><?xml version="1.0" encoding="utf-8"?>
-<p:sld xmlns:a="http://schemas.openxmlformats.org/drawingml/2006/main" xmlns:p="http://schemas.openxmlformats.org/presentationml/2006/main" xmlns:r="http://schemas.openxmlformats.org/officeDocument/2006/relationships">
+<p:sld xmlns:a="http://schemas.openxmlformats.org/drawingml/2006/main" xmlns:r="http://schemas.openxmlformats.org/officeDocument/2006/relationships" xmlns:p="http://schemas.openxmlformats.org/presentationml/2006/main">
   <p:cSld>
     <p:spTree>
       <p:nvGrpSpPr>
@@ -3375,10 +3339,9 @@
           </a:ln>
         </p:spPr>
         <p:txBody>
-          <a:bodyPr wrap="square" lIns="0" rIns="0" tIns="0" bIns="0" anchor="ctr"/>
-          <a:lstStyle/>
-          <a:p>
-            <a:pPr/>
+          <a:bodyPr wrap="square" lIns="0" tIns="0" rIns="0" bIns="0" anchor="ctr"/>
+          <a:lstStyle/>
+          <a:p>
             <a:r>
               <a:rPr lang="en-US" sz="1100" b="1">
                 <a:solidFill>
@@ -3412,10 +3375,9 @@
           </a:ln>
         </p:spPr>
         <p:txBody>
-          <a:bodyPr wrap="square" lIns="0" rIns="0" tIns="0" bIns="0" anchor="ctr"/>
-          <a:lstStyle/>
-          <a:p>
-            <a:pPr/>
+          <a:bodyPr wrap="square" lIns="0" tIns="0" rIns="0" bIns="0" anchor="ctr"/>
+          <a:lstStyle/>
+          <a:p>
             <a:r>
               <a:rPr lang="en-US" sz="2700" b="1">
                 <a:solidFill>
@@ -3471,10 +3433,9 @@
           </a:ln>
         </p:spPr>
         <p:txBody>
-          <a:bodyPr wrap="square" lIns="0" rIns="0" tIns="0" bIns="0" anchor="ctr"/>
-          <a:lstStyle/>
-          <a:p>
-            <a:pPr/>
+          <a:bodyPr wrap="square" lIns="0" tIns="0" rIns="0" bIns="0" anchor="ctr"/>
+          <a:lstStyle/>
+          <a:p>
             <a:r>
               <a:rPr lang="en-US" sz="900" b="0">
                 <a:solidFill>
@@ -3508,10 +3469,9 @@
           </a:ln>
         </p:spPr>
         <p:txBody>
-          <a:bodyPr wrap="square" lIns="0" rIns="0" tIns="0" bIns="0" anchor="ctr"/>
-          <a:lstStyle/>
-          <a:p>
-            <a:pPr/>
+          <a:bodyPr wrap="square" lIns="0" tIns="0" rIns="0" bIns="0" anchor="ctr"/>
+          <a:lstStyle/>
+          <a:p>
             <a:r>
               <a:rPr lang="en-US" sz="900" b="0">
                 <a:solidFill>
@@ -3567,10 +3527,9 @@
           </a:ln>
         </p:spPr>
         <p:txBody>
-          <a:bodyPr wrap="square" lIns="0" rIns="0" tIns="0" bIns="0" anchor="ctr"/>
-          <a:lstStyle/>
-          <a:p>
-            <a:pPr/>
+          <a:bodyPr wrap="square" lIns="0" tIns="0" rIns="0" bIns="0" anchor="ctr"/>
+          <a:lstStyle/>
+          <a:p>
             <a:r>
               <a:rPr lang="en-US" sz="1400" b="1">
                 <a:solidFill>
@@ -3721,5 +3680,7 @@
       </a:bgFillStyleLst>
     </a:fmtScheme>
   </a:themeElements>
+  <a:objectDefaults/>
+  <a:extraClrSchemeLst/>
 </a:theme>
 </file>
</xml_diff>